<commit_message>
Fix text overlaps across all presentation slides
Separate section labels from titles with proper vertical spacing.
Eliminate revenue list overlap with competitive pressure card on
slide 2. Reposition closing summary below action cards on slide 8.
Tighten metric card internal spacing to prevent label/value overlap.
</commit_message>
<xml_diff>
--- a/presentation/SRAM_AI_Adoption_Playbook.pptx
+++ b/presentation/SRAM_AI_Adoption_Playbook.pptx
@@ -3316,8 +3316,8 @@
         </p:nvSpPr>
         <p:spPr>
           <a:xfrm>
-            <a:off x="731520" y="365760"/>
-            <a:ext cx="5486400" cy="457200"/>
+            <a:off x="731520" y="274320"/>
+            <a:ext cx="5486400" cy="274320"/>
           </a:xfrm>
           <a:prstGeom prst="rect">
             <a:avLst/>
@@ -3352,8 +3352,8 @@
         </p:nvSpPr>
         <p:spPr>
           <a:xfrm>
-            <a:off x="731520" y="640080"/>
-            <a:ext cx="9144000" cy="640080"/>
+            <a:off x="731520" y="594360"/>
+            <a:ext cx="9144000" cy="457200"/>
           </a:xfrm>
           <a:prstGeom prst="rect">
             <a:avLst/>
@@ -3388,7 +3388,7 @@
         </p:nvSpPr>
         <p:spPr>
           <a:xfrm>
-            <a:off x="731520" y="1188720"/>
+            <a:off x="731520" y="1097280"/>
             <a:ext cx="1097280" cy="38100"/>
           </a:xfrm>
           <a:prstGeom prst="rect">
@@ -3431,8 +3431,8 @@
         </p:nvSpPr>
         <p:spPr>
           <a:xfrm>
-            <a:off x="731520" y="1463040"/>
-            <a:ext cx="5029200" cy="914400"/>
+            <a:off x="731520" y="1325880"/>
+            <a:ext cx="6858000" cy="731520"/>
           </a:xfrm>
           <a:prstGeom prst="rect">
             <a:avLst/>
@@ -3467,7 +3467,7 @@
         </p:nvSpPr>
         <p:spPr>
           <a:xfrm>
-            <a:off x="731520" y="2560320"/>
+            <a:off x="731520" y="2286000"/>
             <a:ext cx="2286000" cy="1371600"/>
           </a:xfrm>
           <a:prstGeom prst="roundRect">
@@ -3514,8 +3514,8 @@
         </p:nvSpPr>
         <p:spPr>
           <a:xfrm>
-            <a:off x="1005840" y="2788920"/>
-            <a:ext cx="1737360" cy="365760"/>
+            <a:off x="1005840" y="2423160"/>
+            <a:ext cx="1737360" cy="274320"/>
           </a:xfrm>
           <a:prstGeom prst="rect">
             <a:avLst/>
@@ -3550,8 +3550,8 @@
         </p:nvSpPr>
         <p:spPr>
           <a:xfrm>
-            <a:off x="1005840" y="3063240"/>
-            <a:ext cx="1737360" cy="548640"/>
+            <a:off x="1005840" y="2697480"/>
+            <a:ext cx="1737360" cy="457200"/>
           </a:xfrm>
           <a:prstGeom prst="rect">
             <a:avLst/>
@@ -3586,7 +3586,7 @@
         </p:nvSpPr>
         <p:spPr>
           <a:xfrm>
-            <a:off x="1005840" y="3611880"/>
+            <a:off x="1005840" y="3200400"/>
             <a:ext cx="1737360" cy="274320"/>
           </a:xfrm>
           <a:prstGeom prst="rect">
@@ -3622,7 +3622,7 @@
         </p:nvSpPr>
         <p:spPr>
           <a:xfrm>
-            <a:off x="3200400" y="2560320"/>
+            <a:off x="3200400" y="2286000"/>
             <a:ext cx="2286000" cy="1371600"/>
           </a:xfrm>
           <a:prstGeom prst="roundRect">
@@ -3669,8 +3669,8 @@
         </p:nvSpPr>
         <p:spPr>
           <a:xfrm>
-            <a:off x="3474720" y="2788920"/>
-            <a:ext cx="1737360" cy="365760"/>
+            <a:off x="3474720" y="2423160"/>
+            <a:ext cx="1737360" cy="274320"/>
           </a:xfrm>
           <a:prstGeom prst="rect">
             <a:avLst/>
@@ -3705,8 +3705,8 @@
         </p:nvSpPr>
         <p:spPr>
           <a:xfrm>
-            <a:off x="3474720" y="3063240"/>
-            <a:ext cx="1737360" cy="548640"/>
+            <a:off x="3474720" y="2697480"/>
+            <a:ext cx="1737360" cy="457200"/>
           </a:xfrm>
           <a:prstGeom prst="rect">
             <a:avLst/>
@@ -3741,7 +3741,7 @@
         </p:nvSpPr>
         <p:spPr>
           <a:xfrm>
-            <a:off x="3474720" y="3611880"/>
+            <a:off x="3474720" y="3200400"/>
             <a:ext cx="1737360" cy="274320"/>
           </a:xfrm>
           <a:prstGeom prst="rect">
@@ -3777,7 +3777,7 @@
         </p:nvSpPr>
         <p:spPr>
           <a:xfrm>
-            <a:off x="5669280" y="2560320"/>
+            <a:off x="5669280" y="2286000"/>
             <a:ext cx="2286000" cy="1371600"/>
           </a:xfrm>
           <a:prstGeom prst="roundRect">
@@ -3824,8 +3824,8 @@
         </p:nvSpPr>
         <p:spPr>
           <a:xfrm>
-            <a:off x="5943600" y="2788920"/>
-            <a:ext cx="1737360" cy="365760"/>
+            <a:off x="5943600" y="2423160"/>
+            <a:ext cx="1737360" cy="274320"/>
           </a:xfrm>
           <a:prstGeom prst="rect">
             <a:avLst/>
@@ -3860,8 +3860,8 @@
         </p:nvSpPr>
         <p:spPr>
           <a:xfrm>
-            <a:off x="5943600" y="3063240"/>
-            <a:ext cx="1737360" cy="548640"/>
+            <a:off x="5943600" y="2697480"/>
+            <a:ext cx="1737360" cy="457200"/>
           </a:xfrm>
           <a:prstGeom prst="rect">
             <a:avLst/>
@@ -3896,7 +3896,7 @@
         </p:nvSpPr>
         <p:spPr>
           <a:xfrm>
-            <a:off x="5943600" y="3611880"/>
+            <a:off x="5943600" y="3200400"/>
             <a:ext cx="1737360" cy="274320"/>
           </a:xfrm>
           <a:prstGeom prst="rect">
@@ -3932,7 +3932,7 @@
         </p:nvSpPr>
         <p:spPr>
           <a:xfrm>
-            <a:off x="8138160" y="2560320"/>
+            <a:off x="8138160" y="2286000"/>
             <a:ext cx="2286000" cy="1371600"/>
           </a:xfrm>
           <a:prstGeom prst="roundRect">
@@ -3979,8 +3979,8 @@
         </p:nvSpPr>
         <p:spPr>
           <a:xfrm>
-            <a:off x="8412480" y="2788920"/>
-            <a:ext cx="1737360" cy="365760"/>
+            <a:off x="8412480" y="2423160"/>
+            <a:ext cx="1737360" cy="274320"/>
           </a:xfrm>
           <a:prstGeom prst="rect">
             <a:avLst/>
@@ -4015,8 +4015,8 @@
         </p:nvSpPr>
         <p:spPr>
           <a:xfrm>
-            <a:off x="8412480" y="3063240"/>
-            <a:ext cx="1737360" cy="548640"/>
+            <a:off x="8412480" y="2697480"/>
+            <a:ext cx="1737360" cy="457200"/>
           </a:xfrm>
           <a:prstGeom prst="rect">
             <a:avLst/>
@@ -4051,7 +4051,7 @@
         </p:nvSpPr>
         <p:spPr>
           <a:xfrm>
-            <a:off x="8412480" y="3611880"/>
+            <a:off x="8412480" y="3200400"/>
             <a:ext cx="1737360" cy="274320"/>
           </a:xfrm>
           <a:prstGeom prst="rect">
@@ -4087,7 +4087,7 @@
         </p:nvSpPr>
         <p:spPr>
           <a:xfrm>
-            <a:off x="731520" y="4206240"/>
+            <a:off x="731520" y="3931920"/>
             <a:ext cx="5486400" cy="365760"/>
           </a:xfrm>
           <a:prstGeom prst="rect">
@@ -4123,8 +4123,8 @@
         </p:nvSpPr>
         <p:spPr>
           <a:xfrm>
-            <a:off x="731520" y="4663440"/>
-            <a:ext cx="2743200" cy="320040"/>
+            <a:off x="731520" y="4389120"/>
+            <a:ext cx="2926080" cy="320040"/>
           </a:xfrm>
           <a:prstGeom prst="rect">
             <a:avLst/>
@@ -4159,7 +4159,7 @@
         </p:nvSpPr>
         <p:spPr>
           <a:xfrm>
-            <a:off x="3657600" y="4663440"/>
+            <a:off x="3840480" y="4389120"/>
             <a:ext cx="3657600" cy="320040"/>
           </a:xfrm>
           <a:prstGeom prst="rect">
@@ -4195,8 +4195,44 @@
         </p:nvSpPr>
         <p:spPr>
           <a:xfrm>
-            <a:off x="7498079" y="4663440"/>
-            <a:ext cx="1828800" cy="320040"/>
+            <a:off x="731520" y="4736592"/>
+            <a:ext cx="2926080" cy="320040"/>
+          </a:xfrm>
+          <a:prstGeom prst="rect">
+            <a:avLst/>
+          </a:prstGeom>
+          <a:noFill/>
+        </p:spPr>
+        <p:txBody>
+          <a:bodyPr wrap="square">
+            <a:spAutoFit/>
+          </a:bodyPr>
+          <a:lstStyle/>
+          <a:p>
+            <a:pPr algn="l">
+              <a:defRPr sz="1200" b="1">
+                <a:solidFill>
+                  <a:srgbClr val="389FF5"/>
+                </a:solidFill>
+                <a:latin typeface="Calibri"/>
+              </a:defRPr>
+            </a:pPr>
+            <a:r>
+              <a:t>Suspension</a:t>
+            </a:r>
+          </a:p>
+        </p:txBody>
+      </p:sp>
+      <p:sp>
+        <p:nvSpPr>
+          <p:cNvPr id="26" name="TextBox 25"/>
+          <p:cNvSpPr txBox="1"/>
+          <p:nvPr/>
+        </p:nvSpPr>
+        <p:spPr>
+          <a:xfrm>
+            <a:off x="3840480" y="4736592"/>
+            <a:ext cx="3657600" cy="320040"/>
           </a:xfrm>
           <a:prstGeom prst="rect">
             <a:avLst/>
@@ -4212,62 +4248,278 @@
             <a:pPr algn="l">
               <a:defRPr sz="1100" b="0">
                 <a:solidFill>
+                  <a:srgbClr val="94A3B8"/>
+                </a:solidFill>
+                <a:latin typeface="Calibri"/>
+              </a:defRPr>
+            </a:pPr>
+            <a:r>
+              <a:t>RockShox forks and shocks</a:t>
+            </a:r>
+          </a:p>
+        </p:txBody>
+      </p:sp>
+      <p:sp>
+        <p:nvSpPr>
+          <p:cNvPr id="27" name="TextBox 26"/>
+          <p:cNvSpPr txBox="1"/>
+          <p:nvPr/>
+        </p:nvSpPr>
+        <p:spPr>
+          <a:xfrm>
+            <a:off x="731520" y="5084064"/>
+            <a:ext cx="2926080" cy="320040"/>
+          </a:xfrm>
+          <a:prstGeom prst="rect">
+            <a:avLst/>
+          </a:prstGeom>
+          <a:noFill/>
+        </p:spPr>
+        <p:txBody>
+          <a:bodyPr wrap="square">
+            <a:spAutoFit/>
+          </a:bodyPr>
+          <a:lstStyle/>
+          <a:p>
+            <a:pPr algn="l">
+              <a:defRPr sz="1200" b="1">
+                <a:solidFill>
+                  <a:srgbClr val="389FF5"/>
+                </a:solidFill>
+                <a:latin typeface="Calibri"/>
+              </a:defRPr>
+            </a:pPr>
+            <a:r>
+              <a:t>Wheels + Cockpit</a:t>
+            </a:r>
+          </a:p>
+        </p:txBody>
+      </p:sp>
+      <p:sp>
+        <p:nvSpPr>
+          <p:cNvPr id="28" name="TextBox 27"/>
+          <p:cNvSpPr txBox="1"/>
+          <p:nvPr/>
+        </p:nvSpPr>
+        <p:spPr>
+          <a:xfrm>
+            <a:off x="3840480" y="5084064"/>
+            <a:ext cx="3657600" cy="320040"/>
+          </a:xfrm>
+          <a:prstGeom prst="rect">
+            <a:avLst/>
+          </a:prstGeom>
+          <a:noFill/>
+        </p:spPr>
+        <p:txBody>
+          <a:bodyPr wrap="square">
+            <a:spAutoFit/>
+          </a:bodyPr>
+          <a:lstStyle/>
+          <a:p>
+            <a:pPr algn="l">
+              <a:defRPr sz="1100" b="0">
+                <a:solidFill>
+                  <a:srgbClr val="94A3B8"/>
+                </a:solidFill>
+                <a:latin typeface="Calibri"/>
+              </a:defRPr>
+            </a:pPr>
+            <a:r>
+              <a:t>Zipp performance components</a:t>
+            </a:r>
+          </a:p>
+        </p:txBody>
+      </p:sp>
+      <p:sp>
+        <p:nvSpPr>
+          <p:cNvPr id="29" name="TextBox 28"/>
+          <p:cNvSpPr txBox="1"/>
+          <p:nvPr/>
+        </p:nvSpPr>
+        <p:spPr>
+          <a:xfrm>
+            <a:off x="731520" y="5431536"/>
+            <a:ext cx="2926080" cy="320040"/>
+          </a:xfrm>
+          <a:prstGeom prst="rect">
+            <a:avLst/>
+          </a:prstGeom>
+          <a:noFill/>
+        </p:spPr>
+        <p:txBody>
+          <a:bodyPr wrap="square">
+            <a:spAutoFit/>
+          </a:bodyPr>
+          <a:lstStyle/>
+          <a:p>
+            <a:pPr algn="l">
+              <a:defRPr sz="1200" b="1">
+                <a:solidFill>
+                  <a:srgbClr val="34D399"/>
+                </a:solidFill>
+                <a:latin typeface="Calibri"/>
+              </a:defRPr>
+            </a:pPr>
+            <a:r>
+              <a:t>Connected Products</a:t>
+            </a:r>
+          </a:p>
+        </p:txBody>
+      </p:sp>
+      <p:sp>
+        <p:nvSpPr>
+          <p:cNvPr id="30" name="TextBox 29"/>
+          <p:cNvSpPr txBox="1"/>
+          <p:nvPr/>
+        </p:nvSpPr>
+        <p:spPr>
+          <a:xfrm>
+            <a:off x="3840480" y="5431536"/>
+            <a:ext cx="3657600" cy="320040"/>
+          </a:xfrm>
+          <a:prstGeom prst="rect">
+            <a:avLst/>
+          </a:prstGeom>
+          <a:noFill/>
+        </p:spPr>
+        <p:txBody>
+          <a:bodyPr wrap="square">
+            <a:spAutoFit/>
+          </a:bodyPr>
+          <a:lstStyle/>
+          <a:p>
+            <a:pPr algn="l">
+              <a:defRPr sz="1100" b="0">
+                <a:solidFill>
+                  <a:srgbClr val="94A3B8"/>
+                </a:solidFill>
+                <a:latin typeface="Calibri"/>
+              </a:defRPr>
+            </a:pPr>
+            <a:r>
+              <a:t>Hammerhead Karoo, Quarq power</a:t>
+            </a:r>
+          </a:p>
+        </p:txBody>
+      </p:sp>
+      <p:sp>
+        <p:nvSpPr>
+          <p:cNvPr id="31" name="TextBox 30"/>
+          <p:cNvSpPr txBox="1"/>
+          <p:nvPr/>
+        </p:nvSpPr>
+        <p:spPr>
+          <a:xfrm>
+            <a:off x="731520" y="5779008"/>
+            <a:ext cx="2926080" cy="320040"/>
+          </a:xfrm>
+          <a:prstGeom prst="rect">
+            <a:avLst/>
+          </a:prstGeom>
+          <a:noFill/>
+        </p:spPr>
+        <p:txBody>
+          <a:bodyPr wrap="square">
+            <a:spAutoFit/>
+          </a:bodyPr>
+          <a:lstStyle/>
+          <a:p>
+            <a:pPr algn="l">
+              <a:defRPr sz="1200" b="1">
+                <a:solidFill>
+                  <a:srgbClr val="34D399"/>
+                </a:solidFill>
+                <a:latin typeface="Calibri"/>
+              </a:defRPr>
+            </a:pPr>
+            <a:r>
+              <a:t>Wear Parts + Service</a:t>
+            </a:r>
+          </a:p>
+        </p:txBody>
+      </p:sp>
+      <p:sp>
+        <p:nvSpPr>
+          <p:cNvPr id="32" name="TextBox 31"/>
+          <p:cNvSpPr txBox="1"/>
+          <p:nvPr/>
+        </p:nvSpPr>
+        <p:spPr>
+          <a:xfrm>
+            <a:off x="3840480" y="5779008"/>
+            <a:ext cx="3657600" cy="320040"/>
+          </a:xfrm>
+          <a:prstGeom prst="rect">
+            <a:avLst/>
+          </a:prstGeom>
+          <a:noFill/>
+        </p:spPr>
+        <p:txBody>
+          <a:bodyPr wrap="square">
+            <a:spAutoFit/>
+          </a:bodyPr>
+          <a:lstStyle/>
+          <a:p>
+            <a:pPr algn="l">
+              <a:defRPr sz="1100" b="0">
+                <a:solidFill>
+                  <a:srgbClr val="94A3B8"/>
+                </a:solidFill>
+                <a:latin typeface="Calibri"/>
+              </a:defRPr>
+            </a:pPr>
+            <a:r>
+              <a:t>Chains, cassettes, pads, rotors</a:t>
+            </a:r>
+          </a:p>
+        </p:txBody>
+      </p:sp>
+      <p:sp>
+        <p:nvSpPr>
+          <p:cNvPr id="33" name="TextBox 32"/>
+          <p:cNvSpPr txBox="1"/>
+          <p:nvPr/>
+        </p:nvSpPr>
+        <p:spPr>
+          <a:xfrm>
+            <a:off x="731520" y="6126480"/>
+            <a:ext cx="2926080" cy="320040"/>
+          </a:xfrm>
+          <a:prstGeom prst="rect">
+            <a:avLst/>
+          </a:prstGeom>
+          <a:noFill/>
+        </p:spPr>
+        <p:txBody>
+          <a:bodyPr wrap="square">
+            <a:spAutoFit/>
+          </a:bodyPr>
+          <a:lstStyle/>
+          <a:p>
+            <a:pPr algn="l">
+              <a:defRPr sz="1200" b="1">
+                <a:solidFill>
                   <a:srgbClr val="64748B"/>
                 </a:solidFill>
                 <a:latin typeface="Calibri"/>
               </a:defRPr>
             </a:pPr>
             <a:r>
-              <a:t>Core engine</a:t>
-            </a:r>
-          </a:p>
-        </p:txBody>
-      </p:sp>
-      <p:sp>
-        <p:nvSpPr>
-          <p:cNvPr id="26" name="TextBox 25"/>
-          <p:cNvSpPr txBox="1"/>
-          <p:nvPr/>
-        </p:nvSpPr>
-        <p:spPr>
-          <a:xfrm>
-            <a:off x="731520" y="4983480"/>
-            <a:ext cx="2743200" cy="320040"/>
-          </a:xfrm>
-          <a:prstGeom prst="rect">
-            <a:avLst/>
-          </a:prstGeom>
-          <a:noFill/>
-        </p:spPr>
-        <p:txBody>
-          <a:bodyPr wrap="square">
-            <a:spAutoFit/>
-          </a:bodyPr>
-          <a:lstStyle/>
-          <a:p>
-            <a:pPr algn="l">
-              <a:defRPr sz="1200" b="1">
-                <a:solidFill>
-                  <a:srgbClr val="389FF5"/>
-                </a:solidFill>
-                <a:latin typeface="Calibri"/>
-              </a:defRPr>
-            </a:pPr>
-            <a:r>
-              <a:t>Suspension</a:t>
-            </a:r>
-          </a:p>
-        </p:txBody>
-      </p:sp>
-      <p:sp>
-        <p:nvSpPr>
-          <p:cNvPr id="27" name="TextBox 26"/>
-          <p:cNvSpPr txBox="1"/>
-          <p:nvPr/>
-        </p:nvSpPr>
-        <p:spPr>
-          <a:xfrm>
-            <a:off x="3657600" y="4983480"/>
+              <a:t>Pedals + Adjacent</a:t>
+            </a:r>
+          </a:p>
+        </p:txBody>
+      </p:sp>
+      <p:sp>
+        <p:nvSpPr>
+          <p:cNvPr id="34" name="TextBox 33"/>
+          <p:cNvSpPr txBox="1"/>
+          <p:nvPr/>
+        </p:nvSpPr>
+        <p:spPr>
+          <a:xfrm>
+            <a:off x="3840480" y="6126480"/>
             <a:ext cx="3657600" cy="320040"/>
           </a:xfrm>
           <a:prstGeom prst="rect">
@@ -4290,438 +4542,6 @@
               </a:defRPr>
             </a:pPr>
             <a:r>
-              <a:t>RockShox forks and shocks</a:t>
-            </a:r>
-          </a:p>
-        </p:txBody>
-      </p:sp>
-      <p:sp>
-        <p:nvSpPr>
-          <p:cNvPr id="28" name="TextBox 27"/>
-          <p:cNvSpPr txBox="1"/>
-          <p:nvPr/>
-        </p:nvSpPr>
-        <p:spPr>
-          <a:xfrm>
-            <a:off x="7498079" y="4983480"/>
-            <a:ext cx="1828800" cy="320040"/>
-          </a:xfrm>
-          <a:prstGeom prst="rect">
-            <a:avLst/>
-          </a:prstGeom>
-          <a:noFill/>
-        </p:spPr>
-        <p:txBody>
-          <a:bodyPr wrap="square">
-            <a:spAutoFit/>
-          </a:bodyPr>
-          <a:lstStyle/>
-          <a:p>
-            <a:pPr algn="l">
-              <a:defRPr sz="1100" b="0">
-                <a:solidFill>
-                  <a:srgbClr val="64748B"/>
-                </a:solidFill>
-                <a:latin typeface="Calibri"/>
-              </a:defRPr>
-            </a:pPr>
-            <a:r>
-              <a:t>High</a:t>
-            </a:r>
-          </a:p>
-        </p:txBody>
-      </p:sp>
-      <p:sp>
-        <p:nvSpPr>
-          <p:cNvPr id="29" name="TextBox 28"/>
-          <p:cNvSpPr txBox="1"/>
-          <p:nvPr/>
-        </p:nvSpPr>
-        <p:spPr>
-          <a:xfrm>
-            <a:off x="731520" y="5303520"/>
-            <a:ext cx="2743200" cy="320040"/>
-          </a:xfrm>
-          <a:prstGeom prst="rect">
-            <a:avLst/>
-          </a:prstGeom>
-          <a:noFill/>
-        </p:spPr>
-        <p:txBody>
-          <a:bodyPr wrap="square">
-            <a:spAutoFit/>
-          </a:bodyPr>
-          <a:lstStyle/>
-          <a:p>
-            <a:pPr algn="l">
-              <a:defRPr sz="1200" b="1">
-                <a:solidFill>
-                  <a:srgbClr val="389FF5"/>
-                </a:solidFill>
-                <a:latin typeface="Calibri"/>
-              </a:defRPr>
-            </a:pPr>
-            <a:r>
-              <a:t>Wheels + Cockpit</a:t>
-            </a:r>
-          </a:p>
-        </p:txBody>
-      </p:sp>
-      <p:sp>
-        <p:nvSpPr>
-          <p:cNvPr id="30" name="TextBox 29"/>
-          <p:cNvSpPr txBox="1"/>
-          <p:nvPr/>
-        </p:nvSpPr>
-        <p:spPr>
-          <a:xfrm>
-            <a:off x="3657600" y="5303520"/>
-            <a:ext cx="3657600" cy="320040"/>
-          </a:xfrm>
-          <a:prstGeom prst="rect">
-            <a:avLst/>
-          </a:prstGeom>
-          <a:noFill/>
-        </p:spPr>
-        <p:txBody>
-          <a:bodyPr wrap="square">
-            <a:spAutoFit/>
-          </a:bodyPr>
-          <a:lstStyle/>
-          <a:p>
-            <a:pPr algn="l">
-              <a:defRPr sz="1100" b="0">
-                <a:solidFill>
-                  <a:srgbClr val="94A3B8"/>
-                </a:solidFill>
-                <a:latin typeface="Calibri"/>
-              </a:defRPr>
-            </a:pPr>
-            <a:r>
-              <a:t>Zipp performance components</a:t>
-            </a:r>
-          </a:p>
-        </p:txBody>
-      </p:sp>
-      <p:sp>
-        <p:nvSpPr>
-          <p:cNvPr id="31" name="TextBox 30"/>
-          <p:cNvSpPr txBox="1"/>
-          <p:nvPr/>
-        </p:nvSpPr>
-        <p:spPr>
-          <a:xfrm>
-            <a:off x="7498079" y="5303520"/>
-            <a:ext cx="1828800" cy="320040"/>
-          </a:xfrm>
-          <a:prstGeom prst="rect">
-            <a:avLst/>
-          </a:prstGeom>
-          <a:noFill/>
-        </p:spPr>
-        <p:txBody>
-          <a:bodyPr wrap="square">
-            <a:spAutoFit/>
-          </a:bodyPr>
-          <a:lstStyle/>
-          <a:p>
-            <a:pPr algn="l">
-              <a:defRPr sz="1100" b="0">
-                <a:solidFill>
-                  <a:srgbClr val="64748B"/>
-                </a:solidFill>
-                <a:latin typeface="Calibri"/>
-              </a:defRPr>
-            </a:pPr>
-            <a:r>
-              <a:t>Medium</a:t>
-            </a:r>
-          </a:p>
-        </p:txBody>
-      </p:sp>
-      <p:sp>
-        <p:nvSpPr>
-          <p:cNvPr id="32" name="TextBox 31"/>
-          <p:cNvSpPr txBox="1"/>
-          <p:nvPr/>
-        </p:nvSpPr>
-        <p:spPr>
-          <a:xfrm>
-            <a:off x="731520" y="5623559"/>
-            <a:ext cx="2743200" cy="320040"/>
-          </a:xfrm>
-          <a:prstGeom prst="rect">
-            <a:avLst/>
-          </a:prstGeom>
-          <a:noFill/>
-        </p:spPr>
-        <p:txBody>
-          <a:bodyPr wrap="square">
-            <a:spAutoFit/>
-          </a:bodyPr>
-          <a:lstStyle/>
-          <a:p>
-            <a:pPr algn="l">
-              <a:defRPr sz="1200" b="1">
-                <a:solidFill>
-                  <a:srgbClr val="34D399"/>
-                </a:solidFill>
-                <a:latin typeface="Calibri"/>
-              </a:defRPr>
-            </a:pPr>
-            <a:r>
-              <a:t>Connected Products</a:t>
-            </a:r>
-          </a:p>
-        </p:txBody>
-      </p:sp>
-      <p:sp>
-        <p:nvSpPr>
-          <p:cNvPr id="33" name="TextBox 32"/>
-          <p:cNvSpPr txBox="1"/>
-          <p:nvPr/>
-        </p:nvSpPr>
-        <p:spPr>
-          <a:xfrm>
-            <a:off x="3657600" y="5623559"/>
-            <a:ext cx="3657600" cy="320040"/>
-          </a:xfrm>
-          <a:prstGeom prst="rect">
-            <a:avLst/>
-          </a:prstGeom>
-          <a:noFill/>
-        </p:spPr>
-        <p:txBody>
-          <a:bodyPr wrap="square">
-            <a:spAutoFit/>
-          </a:bodyPr>
-          <a:lstStyle/>
-          <a:p>
-            <a:pPr algn="l">
-              <a:defRPr sz="1100" b="0">
-                <a:solidFill>
-                  <a:srgbClr val="94A3B8"/>
-                </a:solidFill>
-                <a:latin typeface="Calibri"/>
-              </a:defRPr>
-            </a:pPr>
-            <a:r>
-              <a:t>Hammerhead Karoo, Quarq power</a:t>
-            </a:r>
-          </a:p>
-        </p:txBody>
-      </p:sp>
-      <p:sp>
-        <p:nvSpPr>
-          <p:cNvPr id="34" name="TextBox 33"/>
-          <p:cNvSpPr txBox="1"/>
-          <p:nvPr/>
-        </p:nvSpPr>
-        <p:spPr>
-          <a:xfrm>
-            <a:off x="7498079" y="5623559"/>
-            <a:ext cx="1828800" cy="320040"/>
-          </a:xfrm>
-          <a:prstGeom prst="rect">
-            <a:avLst/>
-          </a:prstGeom>
-          <a:noFill/>
-        </p:spPr>
-        <p:txBody>
-          <a:bodyPr wrap="square">
-            <a:spAutoFit/>
-          </a:bodyPr>
-          <a:lstStyle/>
-          <a:p>
-            <a:pPr algn="l">
-              <a:defRPr sz="1100" b="0">
-                <a:solidFill>
-                  <a:srgbClr val="64748B"/>
-                </a:solidFill>
-                <a:latin typeface="Calibri"/>
-              </a:defRPr>
-            </a:pPr>
-            <a:r>
-              <a:t>Strategic</a:t>
-            </a:r>
-          </a:p>
-        </p:txBody>
-      </p:sp>
-      <p:sp>
-        <p:nvSpPr>
-          <p:cNvPr id="35" name="TextBox 34"/>
-          <p:cNvSpPr txBox="1"/>
-          <p:nvPr/>
-        </p:nvSpPr>
-        <p:spPr>
-          <a:xfrm>
-            <a:off x="731520" y="5943600"/>
-            <a:ext cx="2743200" cy="320040"/>
-          </a:xfrm>
-          <a:prstGeom prst="rect">
-            <a:avLst/>
-          </a:prstGeom>
-          <a:noFill/>
-        </p:spPr>
-        <p:txBody>
-          <a:bodyPr wrap="square">
-            <a:spAutoFit/>
-          </a:bodyPr>
-          <a:lstStyle/>
-          <a:p>
-            <a:pPr algn="l">
-              <a:defRPr sz="1200" b="1">
-                <a:solidFill>
-                  <a:srgbClr val="34D399"/>
-                </a:solidFill>
-                <a:latin typeface="Calibri"/>
-              </a:defRPr>
-            </a:pPr>
-            <a:r>
-              <a:t>Wear Parts + Service</a:t>
-            </a:r>
-          </a:p>
-        </p:txBody>
-      </p:sp>
-      <p:sp>
-        <p:nvSpPr>
-          <p:cNvPr id="36" name="TextBox 35"/>
-          <p:cNvSpPr txBox="1"/>
-          <p:nvPr/>
-        </p:nvSpPr>
-        <p:spPr>
-          <a:xfrm>
-            <a:off x="3657600" y="5943600"/>
-            <a:ext cx="3657600" cy="320040"/>
-          </a:xfrm>
-          <a:prstGeom prst="rect">
-            <a:avLst/>
-          </a:prstGeom>
-          <a:noFill/>
-        </p:spPr>
-        <p:txBody>
-          <a:bodyPr wrap="square">
-            <a:spAutoFit/>
-          </a:bodyPr>
-          <a:lstStyle/>
-          <a:p>
-            <a:pPr algn="l">
-              <a:defRPr sz="1100" b="0">
-                <a:solidFill>
-                  <a:srgbClr val="94A3B8"/>
-                </a:solidFill>
-                <a:latin typeface="Calibri"/>
-              </a:defRPr>
-            </a:pPr>
-            <a:r>
-              <a:t>Chains, cassettes, pads, rotors</a:t>
-            </a:r>
-          </a:p>
-        </p:txBody>
-      </p:sp>
-      <p:sp>
-        <p:nvSpPr>
-          <p:cNvPr id="37" name="TextBox 36"/>
-          <p:cNvSpPr txBox="1"/>
-          <p:nvPr/>
-        </p:nvSpPr>
-        <p:spPr>
-          <a:xfrm>
-            <a:off x="7498079" y="5943600"/>
-            <a:ext cx="1828800" cy="320040"/>
-          </a:xfrm>
-          <a:prstGeom prst="rect">
-            <a:avLst/>
-          </a:prstGeom>
-          <a:noFill/>
-        </p:spPr>
-        <p:txBody>
-          <a:bodyPr wrap="square">
-            <a:spAutoFit/>
-          </a:bodyPr>
-          <a:lstStyle/>
-          <a:p>
-            <a:pPr algn="l">
-              <a:defRPr sz="1100" b="0">
-                <a:solidFill>
-                  <a:srgbClr val="64748B"/>
-                </a:solidFill>
-                <a:latin typeface="Calibri"/>
-              </a:defRPr>
-            </a:pPr>
-            <a:r>
-              <a:t>Recurring</a:t>
-            </a:r>
-          </a:p>
-        </p:txBody>
-      </p:sp>
-      <p:sp>
-        <p:nvSpPr>
-          <p:cNvPr id="38" name="TextBox 37"/>
-          <p:cNvSpPr txBox="1"/>
-          <p:nvPr/>
-        </p:nvSpPr>
-        <p:spPr>
-          <a:xfrm>
-            <a:off x="731520" y="6263640"/>
-            <a:ext cx="2743200" cy="320040"/>
-          </a:xfrm>
-          <a:prstGeom prst="rect">
-            <a:avLst/>
-          </a:prstGeom>
-          <a:noFill/>
-        </p:spPr>
-        <p:txBody>
-          <a:bodyPr wrap="square">
-            <a:spAutoFit/>
-          </a:bodyPr>
-          <a:lstStyle/>
-          <a:p>
-            <a:pPr algn="l">
-              <a:defRPr sz="1200" b="1">
-                <a:solidFill>
-                  <a:srgbClr val="64748B"/>
-                </a:solidFill>
-                <a:latin typeface="Calibri"/>
-              </a:defRPr>
-            </a:pPr>
-            <a:r>
-              <a:t>Pedals + Adjacent</a:t>
-            </a:r>
-          </a:p>
-        </p:txBody>
-      </p:sp>
-      <p:sp>
-        <p:nvSpPr>
-          <p:cNvPr id="39" name="TextBox 38"/>
-          <p:cNvSpPr txBox="1"/>
-          <p:nvPr/>
-        </p:nvSpPr>
-        <p:spPr>
-          <a:xfrm>
-            <a:off x="3657600" y="6263640"/>
-            <a:ext cx="3657600" cy="320040"/>
-          </a:xfrm>
-          <a:prstGeom prst="rect">
-            <a:avLst/>
-          </a:prstGeom>
-          <a:noFill/>
-        </p:spPr>
-        <p:txBody>
-          <a:bodyPr wrap="square">
-            <a:spAutoFit/>
-          </a:bodyPr>
-          <a:lstStyle/>
-          <a:p>
-            <a:pPr algn="l">
-              <a:defRPr sz="1100" b="0">
-                <a:solidFill>
-                  <a:srgbClr val="94A3B8"/>
-                </a:solidFill>
-                <a:latin typeface="Calibri"/>
-              </a:defRPr>
-            </a:pPr>
-            <a:r>
               <a:t>TIME, Velocio, Ochain</a:t>
             </a:r>
           </a:p>
@@ -4729,50 +4549,14 @@
       </p:sp>
       <p:sp>
         <p:nvSpPr>
-          <p:cNvPr id="40" name="TextBox 39"/>
-          <p:cNvSpPr txBox="1"/>
-          <p:nvPr/>
-        </p:nvSpPr>
-        <p:spPr>
-          <a:xfrm>
-            <a:off x="7498079" y="6263640"/>
-            <a:ext cx="1828800" cy="320040"/>
-          </a:xfrm>
-          <a:prstGeom prst="rect">
-            <a:avLst/>
-          </a:prstGeom>
-          <a:noFill/>
-        </p:spPr>
-        <p:txBody>
-          <a:bodyPr wrap="square">
-            <a:spAutoFit/>
-          </a:bodyPr>
-          <a:lstStyle/>
-          <a:p>
-            <a:pPr algn="l">
-              <a:defRPr sz="1100" b="0">
-                <a:solidFill>
-                  <a:srgbClr val="64748B"/>
-                </a:solidFill>
-                <a:latin typeface="Calibri"/>
-              </a:defRPr>
-            </a:pPr>
-            <a:r>
-              <a:t>Growing</a:t>
-            </a:r>
-          </a:p>
-        </p:txBody>
-      </p:sp>
-      <p:sp>
-        <p:nvSpPr>
-          <p:cNvPr id="41" name="Rounded Rectangle 40"/>
+          <p:cNvPr id="35" name="Rounded Rectangle 34"/>
           <p:cNvSpPr/>
           <p:nvPr/>
         </p:nvSpPr>
         <p:spPr>
           <a:xfrm>
-            <a:off x="8686800" y="4206240"/>
-            <a:ext cx="3017520" cy="2286000"/>
+            <a:off x="8138160" y="3931920"/>
+            <a:ext cx="3474720" cy="2560320"/>
           </a:xfrm>
           <a:prstGeom prst="roundRect">
             <a:avLst>
@@ -4812,14 +4596,14 @@
       </p:sp>
       <p:sp>
         <p:nvSpPr>
-          <p:cNvPr id="42" name="TextBox 41"/>
-          <p:cNvSpPr txBox="1"/>
-          <p:nvPr/>
-        </p:nvSpPr>
-        <p:spPr>
-          <a:xfrm>
-            <a:off x="8961120" y="4389120"/>
-            <a:ext cx="2468880" cy="365760"/>
+          <p:cNvPr id="36" name="TextBox 35"/>
+          <p:cNvSpPr txBox="1"/>
+          <p:nvPr/>
+        </p:nvSpPr>
+        <p:spPr>
+          <a:xfrm>
+            <a:off x="8412480" y="4114800"/>
+            <a:ext cx="2926080" cy="365760"/>
           </a:xfrm>
           <a:prstGeom prst="rect">
             <a:avLst/>
@@ -4848,14 +4632,14 @@
       </p:sp>
       <p:sp>
         <p:nvSpPr>
-          <p:cNvPr id="43" name="TextBox 42"/>
-          <p:cNvSpPr txBox="1"/>
-          <p:nvPr/>
-        </p:nvSpPr>
-        <p:spPr>
-          <a:xfrm>
-            <a:off x="8961120" y="4800600"/>
-            <a:ext cx="2468880" cy="1508760"/>
+          <p:cNvPr id="37" name="TextBox 36"/>
+          <p:cNvSpPr txBox="1"/>
+          <p:nvPr/>
+        </p:nvSpPr>
+        <p:spPr>
+          <a:xfrm>
+            <a:off x="8412480" y="4526280"/>
+            <a:ext cx="2926080" cy="1783080"/>
           </a:xfrm>
           <a:prstGeom prst="rect">
             <a:avLst/>
@@ -4951,8 +4735,8 @@
         </p:nvSpPr>
         <p:spPr>
           <a:xfrm>
-            <a:off x="731520" y="365760"/>
-            <a:ext cx="5486400" cy="457200"/>
+            <a:off x="731520" y="274320"/>
+            <a:ext cx="5486400" cy="274320"/>
           </a:xfrm>
           <a:prstGeom prst="rect">
             <a:avLst/>
@@ -4987,8 +4771,8 @@
         </p:nvSpPr>
         <p:spPr>
           <a:xfrm>
-            <a:off x="731520" y="640080"/>
-            <a:ext cx="9144000" cy="640080"/>
+            <a:off x="731520" y="594360"/>
+            <a:ext cx="9144000" cy="457200"/>
           </a:xfrm>
           <a:prstGeom prst="rect">
             <a:avLst/>
@@ -5023,7 +4807,7 @@
         </p:nvSpPr>
         <p:spPr>
           <a:xfrm>
-            <a:off x="731520" y="1188720"/>
+            <a:off x="731520" y="1097280"/>
             <a:ext cx="1097280" cy="38100"/>
           </a:xfrm>
           <a:prstGeom prst="rect">
@@ -5066,8 +4850,8 @@
         </p:nvSpPr>
         <p:spPr>
           <a:xfrm>
-            <a:off x="731520" y="1463040"/>
-            <a:ext cx="10058400" cy="548640"/>
+            <a:off x="731520" y="1325880"/>
+            <a:ext cx="10058400" cy="457200"/>
           </a:xfrm>
           <a:prstGeom prst="rect">
             <a:avLst/>
@@ -6384,8 +6168,8 @@
         </p:nvSpPr>
         <p:spPr>
           <a:xfrm>
-            <a:off x="731520" y="365760"/>
-            <a:ext cx="5486400" cy="457200"/>
+            <a:off x="731520" y="274320"/>
+            <a:ext cx="5486400" cy="274320"/>
           </a:xfrm>
           <a:prstGeom prst="rect">
             <a:avLst/>
@@ -6420,8 +6204,8 @@
         </p:nvSpPr>
         <p:spPr>
           <a:xfrm>
-            <a:off x="731520" y="640080"/>
-            <a:ext cx="9144000" cy="640080"/>
+            <a:off x="731520" y="594360"/>
+            <a:ext cx="9144000" cy="457200"/>
           </a:xfrm>
           <a:prstGeom prst="rect">
             <a:avLst/>
@@ -6456,7 +6240,7 @@
         </p:nvSpPr>
         <p:spPr>
           <a:xfrm>
-            <a:off x="731520" y="1188720"/>
+            <a:off x="731520" y="1097280"/>
             <a:ext cx="1097280" cy="38100"/>
           </a:xfrm>
           <a:prstGeom prst="rect">
@@ -6499,8 +6283,8 @@
         </p:nvSpPr>
         <p:spPr>
           <a:xfrm>
-            <a:off x="731520" y="1463040"/>
-            <a:ext cx="10058400" cy="548640"/>
+            <a:off x="731520" y="1325880"/>
+            <a:ext cx="10058400" cy="457200"/>
           </a:xfrm>
           <a:prstGeom prst="rect">
             <a:avLst/>
@@ -6582,8 +6366,8 @@
         </p:nvSpPr>
         <p:spPr>
           <a:xfrm>
-            <a:off x="1005840" y="2514600"/>
-            <a:ext cx="2651760" cy="365760"/>
+            <a:off x="1005840" y="2423160"/>
+            <a:ext cx="2651760" cy="274320"/>
           </a:xfrm>
           <a:prstGeom prst="rect">
             <a:avLst/>
@@ -6618,8 +6402,8 @@
         </p:nvSpPr>
         <p:spPr>
           <a:xfrm>
-            <a:off x="1005840" y="2788920"/>
-            <a:ext cx="2651760" cy="548640"/>
+            <a:off x="1005840" y="2697480"/>
+            <a:ext cx="2651760" cy="457200"/>
           </a:xfrm>
           <a:prstGeom prst="rect">
             <a:avLst/>
@@ -6654,7 +6438,7 @@
         </p:nvSpPr>
         <p:spPr>
           <a:xfrm>
-            <a:off x="1005840" y="3337560"/>
+            <a:off x="1005840" y="3200400"/>
             <a:ext cx="2651760" cy="274320"/>
           </a:xfrm>
           <a:prstGeom prst="rect">
@@ -6737,8 +6521,8 @@
         </p:nvSpPr>
         <p:spPr>
           <a:xfrm>
-            <a:off x="4480560" y="2514600"/>
-            <a:ext cx="2651760" cy="365760"/>
+            <a:off x="4480560" y="2423160"/>
+            <a:ext cx="2651760" cy="274320"/>
           </a:xfrm>
           <a:prstGeom prst="rect">
             <a:avLst/>
@@ -6773,8 +6557,8 @@
         </p:nvSpPr>
         <p:spPr>
           <a:xfrm>
-            <a:off x="4480560" y="2788920"/>
-            <a:ext cx="2651760" cy="548640"/>
+            <a:off x="4480560" y="2697480"/>
+            <a:ext cx="2651760" cy="457200"/>
           </a:xfrm>
           <a:prstGeom prst="rect">
             <a:avLst/>
@@ -6809,7 +6593,7 @@
         </p:nvSpPr>
         <p:spPr>
           <a:xfrm>
-            <a:off x="4480560" y="3337560"/>
+            <a:off x="4480560" y="3200400"/>
             <a:ext cx="2651760" cy="274320"/>
           </a:xfrm>
           <a:prstGeom prst="rect">
@@ -6892,8 +6676,8 @@
         </p:nvSpPr>
         <p:spPr>
           <a:xfrm>
-            <a:off x="7955280" y="2514600"/>
-            <a:ext cx="3200399" cy="365760"/>
+            <a:off x="7955280" y="2423160"/>
+            <a:ext cx="3200399" cy="274320"/>
           </a:xfrm>
           <a:prstGeom prst="rect">
             <a:avLst/>
@@ -6928,8 +6712,8 @@
         </p:nvSpPr>
         <p:spPr>
           <a:xfrm>
-            <a:off x="7955280" y="2788920"/>
-            <a:ext cx="3200399" cy="548640"/>
+            <a:off x="7955280" y="2697480"/>
+            <a:ext cx="3200399" cy="457200"/>
           </a:xfrm>
           <a:prstGeom prst="rect">
             <a:avLst/>
@@ -6964,7 +6748,7 @@
         </p:nvSpPr>
         <p:spPr>
           <a:xfrm>
-            <a:off x="7955280" y="3337560"/>
+            <a:off x="7955280" y="3200400"/>
             <a:ext cx="3200399" cy="274320"/>
           </a:xfrm>
           <a:prstGeom prst="rect">
@@ -7536,8 +7320,8 @@
         </p:nvSpPr>
         <p:spPr>
           <a:xfrm>
-            <a:off x="731520" y="365760"/>
-            <a:ext cx="5486400" cy="457200"/>
+            <a:off x="731520" y="274320"/>
+            <a:ext cx="5486400" cy="274320"/>
           </a:xfrm>
           <a:prstGeom prst="rect">
             <a:avLst/>
@@ -7572,8 +7356,8 @@
         </p:nvSpPr>
         <p:spPr>
           <a:xfrm>
-            <a:off x="731520" y="640080"/>
-            <a:ext cx="9144000" cy="640080"/>
+            <a:off x="731520" y="594360"/>
+            <a:ext cx="9144000" cy="457200"/>
           </a:xfrm>
           <a:prstGeom prst="rect">
             <a:avLst/>
@@ -7608,7 +7392,7 @@
         </p:nvSpPr>
         <p:spPr>
           <a:xfrm>
-            <a:off x="731520" y="1188720"/>
+            <a:off x="731520" y="1097280"/>
             <a:ext cx="1097280" cy="38100"/>
           </a:xfrm>
           <a:prstGeom prst="rect">
@@ -9124,8 +8908,8 @@
         </p:nvSpPr>
         <p:spPr>
           <a:xfrm>
-            <a:off x="731520" y="365760"/>
-            <a:ext cx="5486400" cy="457200"/>
+            <a:off x="731520" y="274320"/>
+            <a:ext cx="5486400" cy="274320"/>
           </a:xfrm>
           <a:prstGeom prst="rect">
             <a:avLst/>
@@ -9160,8 +8944,8 @@
         </p:nvSpPr>
         <p:spPr>
           <a:xfrm>
-            <a:off x="731520" y="640080"/>
-            <a:ext cx="9144000" cy="640080"/>
+            <a:off x="731520" y="594360"/>
+            <a:ext cx="9144000" cy="457200"/>
           </a:xfrm>
           <a:prstGeom prst="rect">
             <a:avLst/>
@@ -9196,7 +8980,7 @@
         </p:nvSpPr>
         <p:spPr>
           <a:xfrm>
-            <a:off x="731520" y="1188720"/>
+            <a:off x="731520" y="1097280"/>
             <a:ext cx="1097280" cy="38100"/>
           </a:xfrm>
           <a:prstGeom prst="rect">
@@ -9718,8 +9502,8 @@
         </p:nvSpPr>
         <p:spPr>
           <a:xfrm>
-            <a:off x="7132320" y="2148840"/>
-            <a:ext cx="1737360" cy="365760"/>
+            <a:off x="7132320" y="2057400"/>
+            <a:ext cx="1737360" cy="274320"/>
           </a:xfrm>
           <a:prstGeom prst="rect">
             <a:avLst/>
@@ -9754,8 +9538,8 @@
         </p:nvSpPr>
         <p:spPr>
           <a:xfrm>
-            <a:off x="7132320" y="2423160"/>
-            <a:ext cx="1737360" cy="548640"/>
+            <a:off x="7132320" y="2331720"/>
+            <a:ext cx="1737360" cy="457200"/>
           </a:xfrm>
           <a:prstGeom prst="rect">
             <a:avLst/>
@@ -9790,7 +9574,7 @@
         </p:nvSpPr>
         <p:spPr>
           <a:xfrm>
-            <a:off x="7132320" y="2971800"/>
+            <a:off x="7132320" y="2834640"/>
             <a:ext cx="1737360" cy="274320"/>
           </a:xfrm>
           <a:prstGeom prst="rect">
@@ -9873,8 +9657,8 @@
         </p:nvSpPr>
         <p:spPr>
           <a:xfrm>
-            <a:off x="9601200" y="2148840"/>
-            <a:ext cx="1737360" cy="365760"/>
+            <a:off x="9601200" y="2057400"/>
+            <a:ext cx="1737360" cy="274320"/>
           </a:xfrm>
           <a:prstGeom prst="rect">
             <a:avLst/>
@@ -9909,8 +9693,8 @@
         </p:nvSpPr>
         <p:spPr>
           <a:xfrm>
-            <a:off x="9601200" y="2423160"/>
-            <a:ext cx="1737360" cy="548640"/>
+            <a:off x="9601200" y="2331720"/>
+            <a:ext cx="1737360" cy="457200"/>
           </a:xfrm>
           <a:prstGeom prst="rect">
             <a:avLst/>
@@ -9945,7 +9729,7 @@
         </p:nvSpPr>
         <p:spPr>
           <a:xfrm>
-            <a:off x="9601200" y="2971800"/>
+            <a:off x="9601200" y="2834640"/>
             <a:ext cx="1737360" cy="274320"/>
           </a:xfrm>
           <a:prstGeom prst="rect">
@@ -10232,8 +10016,8 @@
         </p:nvSpPr>
         <p:spPr>
           <a:xfrm>
-            <a:off x="731520" y="365760"/>
-            <a:ext cx="5486400" cy="457200"/>
+            <a:off x="731520" y="274320"/>
+            <a:ext cx="5486400" cy="274320"/>
           </a:xfrm>
           <a:prstGeom prst="rect">
             <a:avLst/>
@@ -10268,8 +10052,8 @@
         </p:nvSpPr>
         <p:spPr>
           <a:xfrm>
-            <a:off x="731520" y="640080"/>
-            <a:ext cx="9144000" cy="640080"/>
+            <a:off x="731520" y="594360"/>
+            <a:ext cx="9144000" cy="457200"/>
           </a:xfrm>
           <a:prstGeom prst="rect">
             <a:avLst/>
@@ -10304,7 +10088,7 @@
         </p:nvSpPr>
         <p:spPr>
           <a:xfrm>
-            <a:off x="731520" y="1188720"/>
+            <a:off x="731520" y="1097280"/>
             <a:ext cx="1097280" cy="38100"/>
           </a:xfrm>
           <a:prstGeom prst="rect">
@@ -10347,8 +10131,8 @@
         </p:nvSpPr>
         <p:spPr>
           <a:xfrm>
-            <a:off x="731520" y="1463040"/>
-            <a:ext cx="10058400" cy="548640"/>
+            <a:off x="731520" y="1325880"/>
+            <a:ext cx="10058400" cy="457200"/>
           </a:xfrm>
           <a:prstGeom prst="rect">
             <a:avLst/>
@@ -10968,8 +10752,8 @@
         </p:nvSpPr>
         <p:spPr>
           <a:xfrm>
-            <a:off x="731520" y="365760"/>
-            <a:ext cx="5486400" cy="457200"/>
+            <a:off x="731520" y="274320"/>
+            <a:ext cx="5486400" cy="274320"/>
           </a:xfrm>
           <a:prstGeom prst="rect">
             <a:avLst/>
@@ -11004,8 +10788,8 @@
         </p:nvSpPr>
         <p:spPr>
           <a:xfrm>
-            <a:off x="731520" y="640080"/>
-            <a:ext cx="9144000" cy="640080"/>
+            <a:off x="731520" y="594360"/>
+            <a:ext cx="9144000" cy="457200"/>
           </a:xfrm>
           <a:prstGeom prst="rect">
             <a:avLst/>
@@ -11040,7 +10824,7 @@
         </p:nvSpPr>
         <p:spPr>
           <a:xfrm>
-            <a:off x="731520" y="1188720"/>
+            <a:off x="731520" y="1097280"/>
             <a:ext cx="1097280" cy="38100"/>
           </a:xfrm>
           <a:prstGeom prst="rect">
@@ -11083,8 +10867,8 @@
         </p:nvSpPr>
         <p:spPr>
           <a:xfrm>
-            <a:off x="731520" y="1645920"/>
-            <a:ext cx="10515600" cy="1371600"/>
+            <a:off x="731520" y="1371600"/>
+            <a:ext cx="10515600" cy="1280160"/>
           </a:xfrm>
           <a:prstGeom prst="roundRect">
             <a:avLst>
@@ -11130,8 +10914,8 @@
         </p:nvSpPr>
         <p:spPr>
           <a:xfrm>
-            <a:off x="1097280" y="1965960"/>
-            <a:ext cx="548640" cy="548640"/>
+            <a:off x="1097280" y="1645920"/>
+            <a:ext cx="502920" cy="502920"/>
           </a:xfrm>
           <a:prstGeom prst="ellipse">
             <a:avLst/>
@@ -11162,7 +10946,7 @@
           <a:lstStyle/>
           <a:p>
             <a:pPr algn="ctr">
-              <a:defRPr sz="2200" b="1">
+              <a:defRPr sz="2000" b="1">
                 <a:solidFill>
                   <a:srgbClr val="0F172A"/>
                 </a:solidFill>
@@ -11182,22 +10966,22 @@
         </p:nvSpPr>
         <p:spPr>
           <a:xfrm>
-            <a:off x="2011680" y="1828800"/>
-            <a:ext cx="8686800" cy="457200"/>
-          </a:xfrm>
-          <a:prstGeom prst="rect">
-            <a:avLst/>
-          </a:prstGeom>
-          <a:noFill/>
-        </p:spPr>
-        <p:txBody>
-          <a:bodyPr wrap="square">
-            <a:spAutoFit/>
-          </a:bodyPr>
-          <a:lstStyle/>
-          <a:p>
-            <a:pPr algn="l">
-              <a:defRPr sz="2000" b="1">
+            <a:off x="1920240" y="1508760"/>
+            <a:ext cx="8686800" cy="411480"/>
+          </a:xfrm>
+          <a:prstGeom prst="rect">
+            <a:avLst/>
+          </a:prstGeom>
+          <a:noFill/>
+        </p:spPr>
+        <p:txBody>
+          <a:bodyPr wrap="square">
+            <a:spAutoFit/>
+          </a:bodyPr>
+          <a:lstStyle/>
+          <a:p>
+            <a:pPr algn="l">
+              <a:defRPr sz="1800" b="1">
                 <a:solidFill>
                   <a:srgbClr val="F8FAFC"/>
                 </a:solidFill>
@@ -11218,22 +11002,22 @@
         </p:nvSpPr>
         <p:spPr>
           <a:xfrm>
-            <a:off x="2011680" y="2286000"/>
-            <a:ext cx="8686800" cy="640080"/>
-          </a:xfrm>
-          <a:prstGeom prst="rect">
-            <a:avLst/>
-          </a:prstGeom>
-          <a:noFill/>
-        </p:spPr>
-        <p:txBody>
-          <a:bodyPr wrap="square">
-            <a:spAutoFit/>
-          </a:bodyPr>
-          <a:lstStyle/>
-          <a:p>
-            <a:pPr algn="l">
-              <a:defRPr sz="1300" b="0">
+            <a:off x="1920240" y="1920240"/>
+            <a:ext cx="8686800" cy="594360"/>
+          </a:xfrm>
+          <a:prstGeom prst="rect">
+            <a:avLst/>
+          </a:prstGeom>
+          <a:noFill/>
+        </p:spPr>
+        <p:txBody>
+          <a:bodyPr wrap="square">
+            <a:spAutoFit/>
+          </a:bodyPr>
+          <a:lstStyle/>
+          <a:p>
+            <a:pPr algn="l">
+              <a:defRPr sz="1200" b="0">
                 <a:solidFill>
                   <a:srgbClr val="94A3B8"/>
                 </a:solidFill>
@@ -11254,8 +11038,8 @@
         </p:nvSpPr>
         <p:spPr>
           <a:xfrm>
-            <a:off x="731520" y="3291840"/>
-            <a:ext cx="10515600" cy="1371600"/>
+            <a:off x="731520" y="2880360"/>
+            <a:ext cx="10515600" cy="1280160"/>
           </a:xfrm>
           <a:prstGeom prst="roundRect">
             <a:avLst>
@@ -11301,8 +11085,8 @@
         </p:nvSpPr>
         <p:spPr>
           <a:xfrm>
-            <a:off x="1097280" y="3611880"/>
-            <a:ext cx="548640" cy="548640"/>
+            <a:off x="1097280" y="3154680"/>
+            <a:ext cx="502920" cy="502920"/>
           </a:xfrm>
           <a:prstGeom prst="ellipse">
             <a:avLst/>
@@ -11333,7 +11117,7 @@
           <a:lstStyle/>
           <a:p>
             <a:pPr algn="ctr">
-              <a:defRPr sz="2200" b="1">
+              <a:defRPr sz="2000" b="1">
                 <a:solidFill>
                   <a:srgbClr val="0F172A"/>
                 </a:solidFill>
@@ -11353,22 +11137,22 @@
         </p:nvSpPr>
         <p:spPr>
           <a:xfrm>
-            <a:off x="2011680" y="3474720"/>
-            <a:ext cx="8686800" cy="457200"/>
-          </a:xfrm>
-          <a:prstGeom prst="rect">
-            <a:avLst/>
-          </a:prstGeom>
-          <a:noFill/>
-        </p:spPr>
-        <p:txBody>
-          <a:bodyPr wrap="square">
-            <a:spAutoFit/>
-          </a:bodyPr>
-          <a:lstStyle/>
-          <a:p>
-            <a:pPr algn="l">
-              <a:defRPr sz="2000" b="1">
+            <a:off x="1920240" y="3017520"/>
+            <a:ext cx="8686800" cy="411480"/>
+          </a:xfrm>
+          <a:prstGeom prst="rect">
+            <a:avLst/>
+          </a:prstGeom>
+          <a:noFill/>
+        </p:spPr>
+        <p:txBody>
+          <a:bodyPr wrap="square">
+            <a:spAutoFit/>
+          </a:bodyPr>
+          <a:lstStyle/>
+          <a:p>
+            <a:pPr algn="l">
+              <a:defRPr sz="1800" b="1">
                 <a:solidFill>
                   <a:srgbClr val="F8FAFC"/>
                 </a:solidFill>
@@ -11389,22 +11173,22 @@
         </p:nvSpPr>
         <p:spPr>
           <a:xfrm>
-            <a:off x="2011680" y="3931920"/>
-            <a:ext cx="8686800" cy="640080"/>
-          </a:xfrm>
-          <a:prstGeom prst="rect">
-            <a:avLst/>
-          </a:prstGeom>
-          <a:noFill/>
-        </p:spPr>
-        <p:txBody>
-          <a:bodyPr wrap="square">
-            <a:spAutoFit/>
-          </a:bodyPr>
-          <a:lstStyle/>
-          <a:p>
-            <a:pPr algn="l">
-              <a:defRPr sz="1300" b="0">
+            <a:off x="1920240" y="3429000"/>
+            <a:ext cx="8686800" cy="594360"/>
+          </a:xfrm>
+          <a:prstGeom prst="rect">
+            <a:avLst/>
+          </a:prstGeom>
+          <a:noFill/>
+        </p:spPr>
+        <p:txBody>
+          <a:bodyPr wrap="square">
+            <a:spAutoFit/>
+          </a:bodyPr>
+          <a:lstStyle/>
+          <a:p>
+            <a:pPr algn="l">
+              <a:defRPr sz="1200" b="0">
                 <a:solidFill>
                   <a:srgbClr val="94A3B8"/>
                 </a:solidFill>
@@ -11425,8 +11209,8 @@
         </p:nvSpPr>
         <p:spPr>
           <a:xfrm>
-            <a:off x="731520" y="4937760"/>
-            <a:ext cx="10515600" cy="1371600"/>
+            <a:off x="731520" y="4389120"/>
+            <a:ext cx="10515600" cy="1280160"/>
           </a:xfrm>
           <a:prstGeom prst="roundRect">
             <a:avLst>
@@ -11472,8 +11256,8 @@
         </p:nvSpPr>
         <p:spPr>
           <a:xfrm>
-            <a:off x="1097280" y="5257800"/>
-            <a:ext cx="548640" cy="548640"/>
+            <a:off x="1097280" y="4663440"/>
+            <a:ext cx="502920" cy="502920"/>
           </a:xfrm>
           <a:prstGeom prst="ellipse">
             <a:avLst/>
@@ -11504,7 +11288,7 @@
           <a:lstStyle/>
           <a:p>
             <a:pPr algn="ctr">
-              <a:defRPr sz="2200" b="1">
+              <a:defRPr sz="2000" b="1">
                 <a:solidFill>
                   <a:srgbClr val="0F172A"/>
                 </a:solidFill>
@@ -11524,22 +11308,22 @@
         </p:nvSpPr>
         <p:spPr>
           <a:xfrm>
-            <a:off x="2011680" y="5120640"/>
-            <a:ext cx="8686800" cy="457200"/>
-          </a:xfrm>
-          <a:prstGeom prst="rect">
-            <a:avLst/>
-          </a:prstGeom>
-          <a:noFill/>
-        </p:spPr>
-        <p:txBody>
-          <a:bodyPr wrap="square">
-            <a:spAutoFit/>
-          </a:bodyPr>
-          <a:lstStyle/>
-          <a:p>
-            <a:pPr algn="l">
-              <a:defRPr sz="2000" b="1">
+            <a:off x="1920240" y="4526280"/>
+            <a:ext cx="8686800" cy="411480"/>
+          </a:xfrm>
+          <a:prstGeom prst="rect">
+            <a:avLst/>
+          </a:prstGeom>
+          <a:noFill/>
+        </p:spPr>
+        <p:txBody>
+          <a:bodyPr wrap="square">
+            <a:spAutoFit/>
+          </a:bodyPr>
+          <a:lstStyle/>
+          <a:p>
+            <a:pPr algn="l">
+              <a:defRPr sz="1800" b="1">
                 <a:solidFill>
                   <a:srgbClr val="F8FAFC"/>
                 </a:solidFill>
@@ -11560,22 +11344,22 @@
         </p:nvSpPr>
         <p:spPr>
           <a:xfrm>
-            <a:off x="2011680" y="5577840"/>
-            <a:ext cx="8686800" cy="640080"/>
-          </a:xfrm>
-          <a:prstGeom prst="rect">
-            <a:avLst/>
-          </a:prstGeom>
-          <a:noFill/>
-        </p:spPr>
-        <p:txBody>
-          <a:bodyPr wrap="square">
-            <a:spAutoFit/>
-          </a:bodyPr>
-          <a:lstStyle/>
-          <a:p>
-            <a:pPr algn="l">
-              <a:defRPr sz="1300" b="0">
+            <a:off x="1920240" y="4937760"/>
+            <a:ext cx="8686800" cy="594360"/>
+          </a:xfrm>
+          <a:prstGeom prst="rect">
+            <a:avLst/>
+          </a:prstGeom>
+          <a:noFill/>
+        </p:spPr>
+        <p:txBody>
+          <a:bodyPr wrap="square">
+            <a:spAutoFit/>
+          </a:bodyPr>
+          <a:lstStyle/>
+          <a:p>
+            <a:pPr algn="l">
+              <a:defRPr sz="1200" b="0">
                 <a:solidFill>
                   <a:srgbClr val="94A3B8"/>
                 </a:solidFill>
@@ -11596,17 +11380,21 @@
         </p:nvSpPr>
         <p:spPr>
           <a:xfrm>
-            <a:off x="731520" y="6400800"/>
-            <a:ext cx="10515600" cy="9144"/>
+            <a:off x="731520" y="6172200"/>
+            <a:ext cx="10515600" cy="457200"/>
           </a:xfrm>
           <a:prstGeom prst="roundRect">
-            <a:avLst/>
+            <a:avLst>
+              <a:gd name="adj" fmla="val 10000"/>
+            </a:avLst>
           </a:prstGeom>
           <a:solidFill>
-            <a:srgbClr val="1E293B"/>
+            <a:srgbClr val="16213A"/>
           </a:solidFill>
-          <a:ln>
-            <a:noFill/>
+          <a:ln w="12700">
+            <a:solidFill>
+              <a:srgbClr val="34D399"/>
+            </a:solidFill>
           </a:ln>
         </p:spPr>
         <p:style>
@@ -11639,24 +11427,21 @@
         </p:nvSpPr>
         <p:spPr>
           <a:xfrm>
-            <a:off x="731520" y="5760720"/>
-            <a:ext cx="10515600" cy="640080"/>
-          </a:xfrm>
-          <a:prstGeom prst="rect">
-            <a:avLst/>
-          </a:prstGeom>
-          <a:noFill/>
-        </p:spPr>
-        <p:txBody>
-          <a:bodyPr wrap="square">
-            <a:spAutoFit/>
-          </a:bodyPr>
-          <a:lstStyle/>
-          <a:p>
-            <a:pPr>
-              <a:spcAft>
-                <a:spcPts val="780"/>
-              </a:spcAft>
+            <a:off x="1188720" y="6217920"/>
+            <a:ext cx="9601200" cy="365760"/>
+          </a:xfrm>
+          <a:prstGeom prst="rect">
+            <a:avLst/>
+          </a:prstGeom>
+          <a:noFill/>
+        </p:spPr>
+        <p:txBody>
+          <a:bodyPr wrap="square">
+            <a:spAutoFit/>
+          </a:bodyPr>
+          <a:lstStyle/>
+          <a:p>
+            <a:pPr algn="ctr">
               <a:defRPr sz="1300" b="1">
                 <a:solidFill>
                   <a:srgbClr val="34D399"/>
@@ -11665,7 +11450,7 @@
               </a:defRPr>
             </a:pPr>
             <a:r>
-              <a:t>Expected Year-1 return: 3.8x  |  Downside bounded by 90-day pilot scope  |  Upside scales with SRAM's unique data advantage</a:t>
+              <a:t>Expected Year-1 return: 3.8x  |  Downside bounded by 90-day pilot  |  Upside scales with SRAM's unique data advantage</a:t>
             </a:r>
           </a:p>
         </p:txBody>

</xml_diff>

<commit_message>
Shorten slide titles to fit on one line
Slide 2, 7, and 8 titles were too long for 26pt on 11.5"
width. Shortened to under 55 characters each.
</commit_message>
<xml_diff>
--- a/presentation/SRAM_AI_Adoption_Playbook.pptx
+++ b/presentation/SRAM_AI_Adoption_Playbook.pptx
@@ -7481,7 +7481,7 @@
               </a:defRPr>
             </a:pPr>
             <a:r>
-              <a:t>SRAM sells $1B+ in cycling components through the only fully connected ecosystem</a:t>
+              <a:t>SRAM's connected ecosystem is unmatched in cycling</a:t>
             </a:r>
           </a:p>
         </p:txBody>
@@ -15364,7 +15364,7 @@
               </a:defRPr>
             </a:pPr>
             <a:r>
-              <a:t>Expected Year-1 net value of $10.2M on $2.7M total spend</a:t>
+              <a:t>$10.2M net value in Year 1 on $2.7M spend</a:t>
             </a:r>
           </a:p>
         </p:txBody>
@@ -17180,7 +17180,7 @@
               </a:defRPr>
             </a:pPr>
             <a:r>
-              <a:t>By 2031, SRAM transforms from hardware manufacturer to performance intelligence company</a:t>
+              <a:t>Hardware company to performance intelligence by 2031</a:t>
             </a:r>
           </a:p>
         </p:txBody>

</xml_diff>